<commit_message>
Vecka 42: figurer, texträttelser och filmen Fem steg, granskade
- 20 figurer: strömväg, beröringsspänning, ljusbåge, energikällor ombord (med nödgenerator),
  åtgärder vid elolycka till sjöss (TMAS via JRCC, i hamn 112), arbetsområden, fem
  säkerhetsåtgärder, roller ombord, prova–mät–prova, jordning och kortslutning, riskmatris
- Stödbilder och exempel som inte avslöjar svar, enhetliga begrepp (återinkoppling,
  landanslutning), SS-EN 50110-1 och ESA hålls isär, nedsänkta index
- Filmen Fem steg: huvudtavla och UPS, frånskild men ej kontrollerad före provningen,
  skylt med namn, jordning med kortslutningsskena
- pptxtext.subscript_tokens för index som hela ord

Co-Authored-By: Claude Opus 5.5 <noreply@anthropic.com>
Claude-Session: https://claude.ai/code/session_011V9KjBb53XrDm23Dw58SH3
</commit_message>
<xml_diff>
--- a/sjoskolan/vecka-42/aktuell/v42_01_Elektriska_risker_elev.pptx
+++ b/sjoskolan/vecka-42/aktuell/v42_01_Elektriska_risker_elev.pptx
@@ -3512,6 +3512,10 @@
             <a:noFill/>
           </a:ln>
         </p:spPr>
+        <p:txBody xmlns:a="http://schemas.openxmlformats.org/drawingml/2006/main">
+          <a:bodyPr/>
+          <a:p/>
+        </p:txBody>
       </p:sp>
       <p:sp>
         <p:nvSpPr>
@@ -4348,7 +4352,7 @@
                 <a:ea typeface="Calibri"/>
                 <a:cs typeface="Calibri"/>
               </a:rPr>
-              <a:t>Redovisa din beräkning eller motivera ditt beslut.</a:t>
+              <a:t>Motivera ditt beslut.</a:t>
             </a:r>
           </a:p>
         </p:txBody>
@@ -5072,7 +5076,7 @@
                 <a:ea typeface="Calibri"/>
                 <a:cs typeface="Calibri"/>
               </a:rPr>
-              <a:t>Redovisa din beräkning eller motivera ditt beslut.</a:t>
+              <a:t>Motivera ditt beslut.</a:t>
             </a:r>
           </a:p>
         </p:txBody>
@@ -5255,7 +5259,7 @@
         <p:spPr>
           <a:xfrm xmlns:a="http://schemas.openxmlformats.org/drawingml/2006/main">
             <a:off x="762000" y="1638300"/>
-            <a:ext cx="7620000" cy="876300"/>
+            <a:ext cx="3977639" cy="876300"/>
           </a:xfrm>
           <a:prstGeom xmlns:a="http://schemas.openxmlformats.org/drawingml/2006/main" prst="rect">
             <a:avLst/>
@@ -5290,7 +5294,95 @@
                 <a:ea typeface="Calibri"/>
                 <a:cs typeface="Calibri"/>
               </a:rPr>
-              <a:t>Uberöring = |VA − VB|</a:t>
+              <a:t>U</a:t>
+            </a:r>
+            <a:r>
+              <a:rPr sz="2400" b="1" baseline="-25000">
+                <a:solidFill>
+                  <a:srgbClr val="064F91"/>
+                </a:solidFill>
+                <a:latin typeface="Calibri"/>
+                <a:ea typeface="Calibri"/>
+                <a:cs typeface="Calibri"/>
+              </a:rPr>
+              <a:t>beröring</a:t>
+            </a:r>
+            <a:r>
+              <a:rPr sz="2400" b="1">
+                <a:solidFill>
+                  <a:srgbClr val="064F91"/>
+                </a:solidFill>
+                <a:latin typeface="Calibri"/>
+                <a:ea typeface="Calibri"/>
+                <a:cs typeface="Calibri"/>
+              </a:rPr>
+              <a:t> = |</a:t>
+            </a:r>
+            <a:r>
+              <a:rPr sz="2400" b="1">
+                <a:solidFill>
+                  <a:srgbClr val="064F91"/>
+                </a:solidFill>
+                <a:latin typeface="Calibri"/>
+                <a:ea typeface="Calibri"/>
+                <a:cs typeface="Calibri"/>
+              </a:rPr>
+              <a:t>V</a:t>
+            </a:r>
+            <a:r>
+              <a:rPr sz="2400" b="1" baseline="-25000">
+                <a:solidFill>
+                  <a:srgbClr val="064F91"/>
+                </a:solidFill>
+                <a:latin typeface="Calibri"/>
+                <a:ea typeface="Calibri"/>
+                <a:cs typeface="Calibri"/>
+              </a:rPr>
+              <a:t>A</a:t>
+            </a:r>
+            <a:r>
+              <a:rPr sz="2400" b="1">
+                <a:solidFill>
+                  <a:srgbClr val="064F91"/>
+                </a:solidFill>
+                <a:latin typeface="Calibri"/>
+                <a:ea typeface="Calibri"/>
+                <a:cs typeface="Calibri"/>
+              </a:rPr>
+              <a:t> − </a:t>
+            </a:r>
+            <a:r>
+              <a:rPr sz="2400" b="1">
+                <a:solidFill>
+                  <a:srgbClr val="064F91"/>
+                </a:solidFill>
+                <a:latin typeface="Calibri"/>
+                <a:ea typeface="Calibri"/>
+                <a:cs typeface="Calibri"/>
+              </a:rPr>
+              <a:t>V</a:t>
+            </a:r>
+            <a:r>
+              <a:rPr sz="2400" b="1" baseline="-25000">
+                <a:solidFill>
+                  <a:srgbClr val="064F91"/>
+                </a:solidFill>
+                <a:latin typeface="Calibri"/>
+                <a:ea typeface="Calibri"/>
+                <a:cs typeface="Calibri"/>
+              </a:rPr>
+              <a:t>B</a:t>
+            </a:r>
+            <a:r>
+              <a:rPr sz="2400" b="1">
+                <a:solidFill>
+                  <a:srgbClr val="064F91"/>
+                </a:solidFill>
+                <a:latin typeface="Calibri"/>
+                <a:ea typeface="Calibri"/>
+                <a:cs typeface="Calibri"/>
+              </a:rPr>
+              <a:t>|</a:t>
             </a:r>
           </a:p>
         </p:txBody>
@@ -5312,7 +5404,7 @@
         <p:spPr>
           <a:xfrm xmlns:a="http://schemas.openxmlformats.org/drawingml/2006/main">
             <a:off x="762000" y="2667000"/>
-            <a:ext cx="7620000" cy="952500"/>
+            <a:ext cx="3977639" cy="952500"/>
           </a:xfrm>
           <a:prstGeom xmlns:a="http://schemas.openxmlformats.org/drawingml/2006/main" prst="rect">
             <a:avLst/>
@@ -5339,15 +5431,70 @@
               </a:defRPr>
             </a:pPr>
             <a:r>
-              <a:rPr sz="2100" b="0">
-                <a:solidFill>
-                  <a:srgbClr val="111111"/>
-                </a:solidFill>
-                <a:latin typeface="Calibri"/>
-                <a:ea typeface="Calibri"/>
-                <a:cs typeface="Calibri"/>
-              </a:rPr>
-              <a:t>VA och VB är potentialerna hos två punkter som kan beröras samtidigt.</a:t>
+              <a:rPr sz="2050" b="0">
+                <a:solidFill>
+                  <a:srgbClr val="111111"/>
+                </a:solidFill>
+                <a:latin typeface="Calibri"/>
+                <a:ea typeface="Calibri"/>
+                <a:cs typeface="Calibri"/>
+              </a:rPr>
+              <a:t>V</a:t>
+            </a:r>
+            <a:r>
+              <a:rPr sz="2050" b="0" baseline="-25000">
+                <a:solidFill>
+                  <a:srgbClr val="111111"/>
+                </a:solidFill>
+                <a:latin typeface="Calibri"/>
+                <a:ea typeface="Calibri"/>
+                <a:cs typeface="Calibri"/>
+              </a:rPr>
+              <a:t>A</a:t>
+            </a:r>
+            <a:r>
+              <a:rPr sz="2050" b="0">
+                <a:solidFill>
+                  <a:srgbClr val="111111"/>
+                </a:solidFill>
+                <a:latin typeface="Calibri"/>
+                <a:ea typeface="Calibri"/>
+                <a:cs typeface="Calibri"/>
+              </a:rPr>
+              <a:t> och </a:t>
+            </a:r>
+            <a:r>
+              <a:rPr sz="2050" b="0">
+                <a:solidFill>
+                  <a:srgbClr val="111111"/>
+                </a:solidFill>
+                <a:latin typeface="Calibri"/>
+                <a:ea typeface="Calibri"/>
+                <a:cs typeface="Calibri"/>
+              </a:rPr>
+              <a:t>V</a:t>
+            </a:r>
+            <a:r>
+              <a:rPr sz="2050" b="0" baseline="-25000">
+                <a:solidFill>
+                  <a:srgbClr val="111111"/>
+                </a:solidFill>
+                <a:latin typeface="Calibri"/>
+                <a:ea typeface="Calibri"/>
+                <a:cs typeface="Calibri"/>
+              </a:rPr>
+              <a:t>B</a:t>
+            </a:r>
+            <a:r>
+              <a:rPr sz="2050" b="0">
+                <a:solidFill>
+                  <a:srgbClr val="111111"/>
+                </a:solidFill>
+                <a:latin typeface="Calibri"/>
+                <a:ea typeface="Calibri"/>
+                <a:cs typeface="Calibri"/>
+              </a:rPr>
+              <a:t> är potentialerna hos två punkter som kan beröras samtidigt.</a:t>
             </a:r>
           </a:p>
         </p:txBody>
@@ -5369,7 +5516,7 @@
         <p:spPr>
           <a:xfrm xmlns:a="http://schemas.openxmlformats.org/drawingml/2006/main">
             <a:off x="762000" y="3800475"/>
-            <a:ext cx="7620000" cy="981075"/>
+            <a:ext cx="3977639" cy="981075"/>
           </a:xfrm>
           <a:prstGeom xmlns:a="http://schemas.openxmlformats.org/drawingml/2006/main" prst="rect">
             <a:avLst/>
@@ -5396,15 +5543,15 @@
               </a:defRPr>
             </a:pPr>
             <a:r>
-              <a:rPr sz="2025" b="0">
-                <a:solidFill>
-                  <a:srgbClr val="111111"/>
-                </a:solidFill>
-                <a:latin typeface="Calibri"/>
-                <a:ea typeface="Calibri"/>
-                <a:cs typeface="Calibri"/>
-              </a:rPr>
-              <a:t>Förutsättningar: Hölje och ledande struktur skiljer 60 V i potential. Båda kan beröras samtidigt.</a:t>
+              <a:rPr sz="1700" b="0">
+                <a:solidFill>
+                  <a:srgbClr val="111111"/>
+                </a:solidFill>
+                <a:latin typeface="Calibri"/>
+                <a:ea typeface="Calibri"/>
+                <a:cs typeface="Calibri"/>
+              </a:rPr>
+              <a:t>Förutsättningar: Hölje och ledande struktur skiljer 60 V i potential. Båda kan beröras samtidigt.</a:t>
             </a:r>
           </a:p>
         </p:txBody>
@@ -5426,7 +5573,7 @@
         <p:spPr>
           <a:xfrm xmlns:a="http://schemas.openxmlformats.org/drawingml/2006/main">
             <a:off x="762000" y="5010150"/>
-            <a:ext cx="7620000" cy="990600"/>
+            <a:ext cx="3977639" cy="990600"/>
           </a:xfrm>
           <a:prstGeom xmlns:a="http://schemas.openxmlformats.org/drawingml/2006/main" prst="rect">
             <a:avLst/>
@@ -5453,7 +5600,7 @@
               </a:defRPr>
             </a:pPr>
             <a:r>
-              <a:rPr sz="2025" b="0">
+              <a:rPr sz="1600" b="0">
                 <a:solidFill>
                   <a:srgbClr val="111111"/>
                 </a:solidFill>
@@ -5523,6 +5670,30 @@
           </a:p>
         </p:txBody>
       </p:sp>
+      <p:pic xmlns:a="http://schemas.openxmlformats.org/drawingml/2006/main" xmlns:r="http://schemas.openxmlformats.org/officeDocument/2006/relationships">
+        <p:nvPicPr>
+          <p:cNvPr id="16" name="Figur: En person rör samtidigt punkt A på ett h" descr="En person rör samtidigt punkt A på ett hölje och punkt B på en ledande struktur; höljet ligger 60 V över strukturen, beröringsspänningen okänd"/>
+          <p:cNvPicPr>
+            <a:picLocks noChangeAspect="1"/>
+          </p:cNvPicPr>
+          <p:nvPr/>
+        </p:nvPicPr>
+        <p:blipFill>
+          <a:blip r:embed="rId3"/>
+          <a:stretch>
+            <a:fillRect/>
+          </a:stretch>
+        </p:blipFill>
+        <p:spPr>
+          <a:xfrm>
+            <a:off x="4892040" y="1645920"/>
+            <a:ext cx="3886200" cy="3252383"/>
+          </a:xfrm>
+          <a:prstGeom prst="rect">
+            <a:avLst/>
+          </a:prstGeom>
+        </p:spPr>
+      </p:pic>
     </p:spTree>
     <p:extLst>
       <p:ext uri="{BB962C8B-B14F-4D97-AF65-F5344CB8AC3E}">
@@ -5796,7 +5967,7 @@
                 <a:ea typeface="Calibri"/>
                 <a:cs typeface="Calibri"/>
               </a:rPr>
-              <a:t>Redovisa din beräkning eller motivera ditt beslut.</a:t>
+              <a:t>Motivera ditt beslut.</a:t>
             </a:r>
           </a:p>
         </p:txBody>
@@ -5979,7 +6150,7 @@
         <p:spPr>
           <a:xfrm xmlns:a="http://schemas.openxmlformats.org/drawingml/2006/main">
             <a:off x="762000" y="1638300"/>
-            <a:ext cx="7620000" cy="876300"/>
+            <a:ext cx="3977639" cy="876300"/>
           </a:xfrm>
           <a:prstGeom xmlns:a="http://schemas.openxmlformats.org/drawingml/2006/main" prst="rect">
             <a:avLst/>
@@ -6014,7 +6185,7 @@
                 <a:ea typeface="Calibri"/>
                 <a:cs typeface="Calibri"/>
               </a:rPr>
-              <a:t>I = U/R     I[mA] = 1 000 · I[A]</a:t>
+              <a:t>I = U/R     I[mA] = 1 000 · I[A]</a:t>
             </a:r>
           </a:p>
         </p:txBody>
@@ -6036,7 +6207,7 @@
         <p:spPr>
           <a:xfrm xmlns:a="http://schemas.openxmlformats.org/drawingml/2006/main">
             <a:off x="762000" y="2667000"/>
-            <a:ext cx="7620000" cy="952500"/>
+            <a:ext cx="3977639" cy="952500"/>
           </a:xfrm>
           <a:prstGeom xmlns:a="http://schemas.openxmlformats.org/drawingml/2006/main" prst="rect">
             <a:avLst/>
@@ -6063,7 +6234,7 @@
               </a:defRPr>
             </a:pPr>
             <a:r>
-              <a:rPr sz="2100" b="0">
+              <a:rPr sz="1850" b="0">
                 <a:solidFill>
                   <a:srgbClr val="111111"/>
                 </a:solidFill>
@@ -6093,7 +6264,7 @@
         <p:spPr>
           <a:xfrm xmlns:a="http://schemas.openxmlformats.org/drawingml/2006/main">
             <a:off x="762000" y="3800475"/>
-            <a:ext cx="7620000" cy="981075"/>
+            <a:ext cx="3977639" cy="981075"/>
           </a:xfrm>
           <a:prstGeom xmlns:a="http://schemas.openxmlformats.org/drawingml/2006/main" prst="rect">
             <a:avLst/>
@@ -6120,15 +6291,15 @@
               </a:defRPr>
             </a:pPr>
             <a:r>
-              <a:rPr sz="2025" b="0">
-                <a:solidFill>
-                  <a:srgbClr val="111111"/>
-                </a:solidFill>
-                <a:latin typeface="Calibri"/>
-                <a:ea typeface="Calibri"/>
-                <a:cs typeface="Calibri"/>
-              </a:rPr>
-              <a:t>Förutsättningar: Ren resistiv räknemodell: U = 24 V och R = 2 000 Ω. Värdet på R är ett antagande.</a:t>
+              <a:rPr sz="1700" b="0">
+                <a:solidFill>
+                  <a:srgbClr val="111111"/>
+                </a:solidFill>
+                <a:latin typeface="Calibri"/>
+                <a:ea typeface="Calibri"/>
+                <a:cs typeface="Calibri"/>
+              </a:rPr>
+              <a:t>Förutsättningar: Ren resistiv räknemodell: U = 24 V och R = 2 000 Ω. Värdet på R är ett antagande.</a:t>
             </a:r>
           </a:p>
         </p:txBody>
@@ -6150,7 +6321,7 @@
         <p:spPr>
           <a:xfrm xmlns:a="http://schemas.openxmlformats.org/drawingml/2006/main">
             <a:off x="762000" y="5010150"/>
-            <a:ext cx="7620000" cy="990600"/>
+            <a:ext cx="3977639" cy="990600"/>
           </a:xfrm>
           <a:prstGeom xmlns:a="http://schemas.openxmlformats.org/drawingml/2006/main" prst="rect">
             <a:avLst/>
@@ -6177,7 +6348,7 @@
               </a:defRPr>
             </a:pPr>
             <a:r>
-              <a:rPr sz="2025" b="0">
+              <a:rPr sz="1600" b="0">
                 <a:solidFill>
                   <a:srgbClr val="111111"/>
                 </a:solidFill>
@@ -6247,6 +6418,30 @@
           </a:p>
         </p:txBody>
       </p:sp>
+      <p:pic xmlns:a="http://schemas.openxmlformats.org/drawingml/2006/main" xmlns:r="http://schemas.openxmlformats.org/officeDocument/2006/relationships">
+        <p:nvPicPr>
+          <p:cNvPr id="16" name="Figur: Räknemodell: 24 V likspänning över en an" descr="Räknemodell: 24 V likspänning över en antagen resistans på 2 000 ohm; strömmen okänd"/>
+          <p:cNvPicPr>
+            <a:picLocks noChangeAspect="1"/>
+          </p:cNvPicPr>
+          <p:nvPr/>
+        </p:nvPicPr>
+        <p:blipFill>
+          <a:blip r:embed="rId3"/>
+          <a:stretch>
+            <a:fillRect/>
+          </a:stretch>
+        </p:blipFill>
+        <p:spPr>
+          <a:xfrm>
+            <a:off x="4892040" y="1645920"/>
+            <a:ext cx="3886200" cy="2890202"/>
+          </a:xfrm>
+          <a:prstGeom prst="rect">
+            <a:avLst/>
+          </a:prstGeom>
+        </p:spPr>
+      </p:pic>
     </p:spTree>
     <p:extLst>
       <p:ext uri="{BB962C8B-B14F-4D97-AF65-F5344CB8AC3E}">
@@ -6703,7 +6898,7 @@
         <p:spPr>
           <a:xfrm xmlns:a="http://schemas.openxmlformats.org/drawingml/2006/main">
             <a:off x="762000" y="1638300"/>
-            <a:ext cx="7620000" cy="876300"/>
+            <a:ext cx="3977639" cy="876300"/>
           </a:xfrm>
           <a:prstGeom xmlns:a="http://schemas.openxmlformats.org/drawingml/2006/main" prst="rect">
             <a:avLst/>
@@ -6730,7 +6925,7 @@
               </a:defRPr>
             </a:pPr>
             <a:r>
-              <a:rPr sz="2400" b="1">
+              <a:rPr sz="2200" b="1">
                 <a:solidFill>
                   <a:srgbClr val="064F91"/>
                 </a:solidFill>
@@ -6760,7 +6955,7 @@
         <p:spPr>
           <a:xfrm xmlns:a="http://schemas.openxmlformats.org/drawingml/2006/main">
             <a:off x="762000" y="2667000"/>
-            <a:ext cx="7620000" cy="952500"/>
+            <a:ext cx="3977639" cy="952500"/>
           </a:xfrm>
           <a:prstGeom xmlns:a="http://schemas.openxmlformats.org/drawingml/2006/main" prst="rect">
             <a:avLst/>
@@ -6787,7 +6982,7 @@
               </a:defRPr>
             </a:pPr>
             <a:r>
-              <a:rPr sz="2100" b="0">
+              <a:rPr sz="1850" b="0">
                 <a:solidFill>
                   <a:srgbClr val="111111"/>
                 </a:solidFill>
@@ -6817,7 +7012,7 @@
         <p:spPr>
           <a:xfrm xmlns:a="http://schemas.openxmlformats.org/drawingml/2006/main">
             <a:off x="762000" y="3800475"/>
-            <a:ext cx="7620000" cy="981075"/>
+            <a:ext cx="3977639" cy="981075"/>
           </a:xfrm>
           <a:prstGeom xmlns:a="http://schemas.openxmlformats.org/drawingml/2006/main" prst="rect">
             <a:avLst/>
@@ -6844,7 +7039,7 @@
               </a:defRPr>
             </a:pPr>
             <a:r>
-              <a:rPr sz="2025" b="0">
+              <a:rPr sz="1600" b="0">
                 <a:solidFill>
                   <a:srgbClr val="111111"/>
                 </a:solidFill>
@@ -6874,7 +7069,7 @@
         <p:spPr>
           <a:xfrm xmlns:a="http://schemas.openxmlformats.org/drawingml/2006/main">
             <a:off x="762000" y="5010150"/>
-            <a:ext cx="7620000" cy="990600"/>
+            <a:ext cx="3977639" cy="990600"/>
           </a:xfrm>
           <a:prstGeom xmlns:a="http://schemas.openxmlformats.org/drawingml/2006/main" prst="rect">
             <a:avLst/>
@@ -6901,7 +7096,7 @@
               </a:defRPr>
             </a:pPr>
             <a:r>
-              <a:rPr sz="2025" b="0">
+              <a:rPr sz="1600" b="0">
                 <a:solidFill>
                   <a:srgbClr val="111111"/>
                 </a:solidFill>
@@ -6971,6 +7166,30 @@
           </a:p>
         </p:txBody>
       </p:sp>
+      <p:pic xmlns:a="http://schemas.openxmlformats.org/drawingml/2006/main" xmlns:r="http://schemas.openxmlformats.org/officeDocument/2006/relationships">
+        <p:nvPicPr>
+          <p:cNvPr id="16" name="Figur: Kraftkrets med frånskiljare i okänt läge" descr="Kraftkrets med frånskiljare i okänt läge, kontaktor K1 och motor; styrkretsen med STOPP bruten och en släckt panel. Frågan är om det är spänningslöst"/>
+          <p:cNvPicPr>
+            <a:picLocks noChangeAspect="1"/>
+          </p:cNvPicPr>
+          <p:nvPr/>
+        </p:nvPicPr>
+        <p:blipFill>
+          <a:blip r:embed="rId3"/>
+          <a:stretch>
+            <a:fillRect/>
+          </a:stretch>
+        </p:blipFill>
+        <p:spPr>
+          <a:xfrm>
+            <a:off x="4892040" y="1645920"/>
+            <a:ext cx="3886200" cy="3252383"/>
+          </a:xfrm>
+          <a:prstGeom prst="rect">
+            <a:avLst/>
+          </a:prstGeom>
+        </p:spPr>
+      </p:pic>
     </p:spTree>
     <p:extLst>
       <p:ext uri="{BB962C8B-B14F-4D97-AF65-F5344CB8AC3E}">
@@ -7244,7 +7463,7 @@
                 <a:ea typeface="Calibri"/>
                 <a:cs typeface="Calibri"/>
               </a:rPr>
-              <a:t>Redovisa din beräkning eller motivera ditt beslut.</a:t>
+              <a:t>Motivera ditt beslut.</a:t>
             </a:r>
           </a:p>
         </p:txBody>
@@ -8172,7 +8391,7 @@
         <p:spPr>
           <a:xfrm xmlns:a="http://schemas.openxmlformats.org/drawingml/2006/main">
             <a:off x="762000" y="1619250"/>
-            <a:ext cx="7620000" cy="1466850"/>
+            <a:ext cx="3977639" cy="1466850"/>
           </a:xfrm>
           <a:prstGeom xmlns:a="http://schemas.openxmlformats.org/drawingml/2006/main" prst="rect">
             <a:avLst/>
@@ -8200,7 +8419,7 @@
               </a:defRPr>
             </a:pPr>
             <a:r>
-              <a:rPr sz="2400" b="0">
+              <a:rPr sz="1800" b="0">
                 <a:solidFill>
                   <a:srgbClr val="111111"/>
                 </a:solidFill>
@@ -8224,7 +8443,7 @@
               </a:defRPr>
             </a:pPr>
             <a:r>
-              <a:rPr sz="2400" b="0">
+              <a:rPr sz="1800" b="0">
                 <a:solidFill>
                   <a:srgbClr val="111111"/>
                 </a:solidFill>
@@ -8254,7 +8473,7 @@
         <p:spPr>
           <a:xfrm xmlns:a="http://schemas.openxmlformats.org/drawingml/2006/main">
             <a:off x="762000" y="3200400"/>
-            <a:ext cx="7620000" cy="838200"/>
+            <a:ext cx="3977639" cy="838200"/>
           </a:xfrm>
           <a:prstGeom xmlns:a="http://schemas.openxmlformats.org/drawingml/2006/main" prst="rect">
             <a:avLst/>
@@ -8282,7 +8501,7 @@
               </a:defRPr>
             </a:pPr>
             <a:r>
-              <a:rPr sz="2925" b="1">
+              <a:rPr sz="2500" b="1">
                 <a:solidFill>
                   <a:srgbClr val="064F91"/>
                 </a:solidFill>
@@ -8312,7 +8531,7 @@
         <p:spPr>
           <a:xfrm xmlns:a="http://schemas.openxmlformats.org/drawingml/2006/main">
             <a:off x="762000" y="4429125"/>
-            <a:ext cx="7620000" cy="1352550"/>
+            <a:ext cx="3977639" cy="1352550"/>
           </a:xfrm>
           <a:prstGeom xmlns:a="http://schemas.openxmlformats.org/drawingml/2006/main" prst="rect">
             <a:avLst/>
@@ -8340,7 +8559,7 @@
               </a:defRPr>
             </a:pPr>
             <a:r>
-              <a:rPr sz="2250" b="0">
+              <a:rPr sz="2000" b="0">
                 <a:solidFill>
                   <a:srgbClr val="111111"/>
                 </a:solidFill>
@@ -8364,7 +8583,7 @@
               </a:defRPr>
             </a:pPr>
             <a:r>
-              <a:rPr sz="2250" b="0">
+              <a:rPr sz="2000" b="0">
                 <a:solidFill>
                   <a:srgbClr val="111111"/>
                 </a:solidFill>
@@ -8435,6 +8654,30 @@
           </a:p>
         </p:txBody>
       </p:sp>
+      <p:pic xmlns:a="http://schemas.openxmlformats.org/drawingml/2006/main" xmlns:r="http://schemas.openxmlformats.org/officeDocument/2006/relationships">
+        <p:nvPicPr>
+          <p:cNvPr id="9" name="Figur: Fördelning som kan matas från generator," descr="Fördelning som kan matas från generator, nödgenerator med autostart, landanslutning, batteri och UPS"/>
+          <p:cNvPicPr>
+            <a:picLocks noChangeAspect="1"/>
+          </p:cNvPicPr>
+          <p:nvPr/>
+        </p:nvPicPr>
+        <p:blipFill>
+          <a:blip r:embed="rId3"/>
+          <a:stretch>
+            <a:fillRect/>
+          </a:stretch>
+        </p:blipFill>
+        <p:spPr>
+          <a:xfrm>
+            <a:off x="4892040" y="1645920"/>
+            <a:ext cx="3886200" cy="3252383"/>
+          </a:xfrm>
+          <a:prstGeom prst="rect">
+            <a:avLst/>
+          </a:prstGeom>
+        </p:spPr>
+      </p:pic>
     </p:spTree>
     <p:extLst>
       <p:ext uri="{BB962C8B-B14F-4D97-AF65-F5344CB8AC3E}">
@@ -8556,7 +8799,7 @@
         <p:spPr>
           <a:xfrm xmlns:a="http://schemas.openxmlformats.org/drawingml/2006/main">
             <a:off x="762000" y="1619250"/>
-            <a:ext cx="7620000" cy="1466850"/>
+            <a:ext cx="3977639" cy="1466850"/>
           </a:xfrm>
           <a:prstGeom xmlns:a="http://schemas.openxmlformats.org/drawingml/2006/main" prst="rect">
             <a:avLst/>
@@ -8584,7 +8827,7 @@
               </a:defRPr>
             </a:pPr>
             <a:r>
-              <a:rPr sz="2400" b="0">
+              <a:rPr sz="1800" b="0">
                 <a:solidFill>
                   <a:srgbClr val="111111"/>
                 </a:solidFill>
@@ -8608,15 +8851,15 @@
               </a:defRPr>
             </a:pPr>
             <a:r>
-              <a:rPr sz="2400" b="0">
-                <a:solidFill>
-                  <a:srgbClr val="111111"/>
-                </a:solidFill>
-                <a:latin typeface="Calibri"/>
-                <a:ea typeface="Calibri"/>
-                <a:cs typeface="Calibri"/>
-              </a:rPr>
-              <a:t>Larma 112 vid akut fara och följ räddningsinstruktioner.</a:t>
+              <a:rPr sz="1800" b="0">
+                <a:solidFill>
+                  <a:srgbClr val="111111"/>
+                </a:solidFill>
+                <a:latin typeface="Calibri"/>
+                <a:ea typeface="Calibri"/>
+                <a:cs typeface="Calibri"/>
+              </a:rPr>
+              <a:t>Larma enligt fartygets nödinstruktion. I hamn: 112.</a:t>
             </a:r>
           </a:p>
         </p:txBody>
@@ -8638,7 +8881,7 @@
         <p:spPr>
           <a:xfrm xmlns:a="http://schemas.openxmlformats.org/drawingml/2006/main">
             <a:off x="762000" y="3200400"/>
-            <a:ext cx="7620000" cy="838200"/>
+            <a:ext cx="3977639" cy="838200"/>
           </a:xfrm>
           <a:prstGeom xmlns:a="http://schemas.openxmlformats.org/drawingml/2006/main" prst="rect">
             <a:avLst/>
@@ -8666,7 +8909,7 @@
               </a:defRPr>
             </a:pPr>
             <a:r>
-              <a:rPr sz="2925" b="1">
+              <a:rPr sz="2550" b="1">
                 <a:solidFill>
                   <a:srgbClr val="064F91"/>
                 </a:solidFill>
@@ -8674,7 +8917,7 @@
                 <a:ea typeface="Calibri"/>
                 <a:cs typeface="Calibri"/>
               </a:rPr>
-              <a:t>Kontakta sjukvården efter strömgenomgång</a:t>
+              <a:t>Till sjöss: radiomedicinsk rådgivning (TMAS)</a:t>
             </a:r>
           </a:p>
         </p:txBody>
@@ -8696,7 +8939,7 @@
         <p:spPr>
           <a:xfrm xmlns:a="http://schemas.openxmlformats.org/drawingml/2006/main">
             <a:off x="762000" y="4429125"/>
-            <a:ext cx="7620000" cy="1352550"/>
+            <a:ext cx="3977639" cy="1352550"/>
           </a:xfrm>
           <a:prstGeom xmlns:a="http://schemas.openxmlformats.org/drawingml/2006/main" prst="rect">
             <a:avLst/>
@@ -8724,7 +8967,7 @@
               </a:defRPr>
             </a:pPr>
             <a:r>
-              <a:rPr sz="2250" b="0">
+              <a:rPr sz="1700" b="0">
                 <a:solidFill>
                   <a:srgbClr val="111111"/>
                 </a:solidFill>
@@ -8748,15 +8991,15 @@
               </a:defRPr>
             </a:pPr>
             <a:r>
-              <a:rPr sz="2250" b="0">
-                <a:solidFill>
-                  <a:srgbClr val="111111"/>
-                </a:solidFill>
-                <a:latin typeface="Calibri"/>
-                <a:ea typeface="Calibri"/>
-                <a:cs typeface="Calibri"/>
-              </a:rPr>
-              <a:t>Vid högspänning håll avstånd tills ansvarig säkrat platsen.</a:t>
+              <a:rPr sz="1700" b="0">
+                <a:solidFill>
+                  <a:srgbClr val="111111"/>
+                </a:solidFill>
+                <a:latin typeface="Calibri"/>
+                <a:ea typeface="Calibri"/>
+                <a:cs typeface="Calibri"/>
+              </a:rPr>
+              <a:t>Vid högspänning håll avstånd tills behörig person säkrat platsen.</a:t>
             </a:r>
           </a:p>
         </p:txBody>
@@ -8819,6 +9062,30 @@
           </a:p>
         </p:txBody>
       </p:sp>
+      <p:pic xmlns:a="http://schemas.openxmlformats.org/drawingml/2006/main" xmlns:r="http://schemas.openxmlformats.org/officeDocument/2006/relationships">
+        <p:nvPicPr>
+          <p:cNvPr id="9" name="Figur: Fem steg vid en elolycka ombord: skydda " descr="Fem steg vid en elolycka ombord: skydda dig själv, bryt strömmen om det går säkert, larma enligt nödinstruktionen, andning och HLR när platsen är säker, medicinsk rådgivning. Till sjöss TMAS via JRCC, i hamn 112"/>
+          <p:cNvPicPr>
+            <a:picLocks noChangeAspect="1"/>
+          </p:cNvPicPr>
+          <p:nvPr/>
+        </p:nvPicPr>
+        <p:blipFill>
+          <a:blip r:embed="rId3"/>
+          <a:stretch>
+            <a:fillRect/>
+          </a:stretch>
+        </p:blipFill>
+        <p:spPr>
+          <a:xfrm>
+            <a:off x="4892040" y="1645920"/>
+            <a:ext cx="3886200" cy="3976745"/>
+          </a:xfrm>
+          <a:prstGeom prst="rect">
+            <a:avLst/>
+          </a:prstGeom>
+        </p:spPr>
+      </p:pic>
     </p:spTree>
     <p:extLst>
       <p:ext uri="{BB962C8B-B14F-4D97-AF65-F5344CB8AC3E}">
@@ -9757,7 +10024,7 @@
         <p:spPr>
           <a:xfrm xmlns:a="http://schemas.openxmlformats.org/drawingml/2006/main">
             <a:off x="762000" y="1638300"/>
-            <a:ext cx="7620000" cy="876300"/>
+            <a:ext cx="3977639" cy="876300"/>
           </a:xfrm>
           <a:prstGeom xmlns:a="http://schemas.openxmlformats.org/drawingml/2006/main" prst="rect">
             <a:avLst/>
@@ -9792,7 +10059,62 @@
                 <a:ea typeface="Calibri"/>
                 <a:cs typeface="Calibri"/>
               </a:rPr>
-              <a:t>Ifel ≈ U/Rslinga i en enkel modell</a:t>
+              <a:t>I</a:t>
+            </a:r>
+            <a:r>
+              <a:rPr sz="2400" b="1" baseline="-25000">
+                <a:solidFill>
+                  <a:srgbClr val="064F91"/>
+                </a:solidFill>
+                <a:latin typeface="Calibri"/>
+                <a:ea typeface="Calibri"/>
+                <a:cs typeface="Calibri"/>
+              </a:rPr>
+              <a:t>fel</a:t>
+            </a:r>
+            <a:r>
+              <a:rPr sz="2400" b="1">
+                <a:solidFill>
+                  <a:srgbClr val="064F91"/>
+                </a:solidFill>
+                <a:latin typeface="Calibri"/>
+                <a:ea typeface="Calibri"/>
+                <a:cs typeface="Calibri"/>
+              </a:rPr>
+              <a:t> ≈ U/</a:t>
+            </a:r>
+            <a:r>
+              <a:rPr sz="2400" b="1">
+                <a:solidFill>
+                  <a:srgbClr val="064F91"/>
+                </a:solidFill>
+                <a:latin typeface="Calibri"/>
+                <a:ea typeface="Calibri"/>
+                <a:cs typeface="Calibri"/>
+              </a:rPr>
+              <a:t>R</a:t>
+            </a:r>
+            <a:r>
+              <a:rPr sz="2400" b="1" baseline="-25000">
+                <a:solidFill>
+                  <a:srgbClr val="064F91"/>
+                </a:solidFill>
+                <a:latin typeface="Calibri"/>
+                <a:ea typeface="Calibri"/>
+                <a:cs typeface="Calibri"/>
+              </a:rPr>
+              <a:t>slinga</a:t>
+            </a:r>
+            <a:r>
+              <a:rPr sz="2400" b="1">
+                <a:solidFill>
+                  <a:srgbClr val="064F91"/>
+                </a:solidFill>
+                <a:latin typeface="Calibri"/>
+                <a:ea typeface="Calibri"/>
+                <a:cs typeface="Calibri"/>
+              </a:rPr>
+              <a:t> i en enkel modell</a:t>
             </a:r>
           </a:p>
         </p:txBody>
@@ -9814,7 +10136,7 @@
         <p:spPr>
           <a:xfrm xmlns:a="http://schemas.openxmlformats.org/drawingml/2006/main">
             <a:off x="762000" y="2667000"/>
-            <a:ext cx="7620000" cy="952500"/>
+            <a:ext cx="3977639" cy="952500"/>
           </a:xfrm>
           <a:prstGeom xmlns:a="http://schemas.openxmlformats.org/drawingml/2006/main" prst="rect">
             <a:avLst/>
@@ -9841,7 +10163,7 @@
               </a:defRPr>
             </a:pPr>
             <a:r>
-              <a:rPr sz="2100" b="0">
+              <a:rPr sz="1700" b="0">
                 <a:solidFill>
                   <a:srgbClr val="111111"/>
                 </a:solidFill>
@@ -9871,7 +10193,7 @@
         <p:spPr>
           <a:xfrm xmlns:a="http://schemas.openxmlformats.org/drawingml/2006/main">
             <a:off x="762000" y="3800475"/>
-            <a:ext cx="7620000" cy="981075"/>
+            <a:ext cx="3977639" cy="981075"/>
           </a:xfrm>
           <a:prstGeom xmlns:a="http://schemas.openxmlformats.org/drawingml/2006/main" prst="rect">
             <a:avLst/>
@@ -9898,15 +10220,15 @@
               </a:defRPr>
             </a:pPr>
             <a:r>
-              <a:rPr sz="2025" b="0">
-                <a:solidFill>
-                  <a:srgbClr val="111111"/>
-                </a:solidFill>
-                <a:latin typeface="Calibri"/>
-                <a:ea typeface="Calibri"/>
-                <a:cs typeface="Calibri"/>
-              </a:rPr>
-              <a:t>Förutsättningar: 24 V-batteri med stor kortslutningsförmåga. Ingen total felresistans anges, så exakt ström kan inte beräknas.</a:t>
+              <a:rPr sz="1600" b="0">
+                <a:solidFill>
+                  <a:srgbClr val="111111"/>
+                </a:solidFill>
+                <a:latin typeface="Calibri"/>
+                <a:ea typeface="Calibri"/>
+                <a:cs typeface="Calibri"/>
+              </a:rPr>
+              <a:t>Förutsättningar: 24 V-batteri med stor kortslutningsförmåga. Ingen total felresistans anges, så exakt ström kan inte beräknas.</a:t>
             </a:r>
           </a:p>
         </p:txBody>
@@ -9928,7 +10250,7 @@
         <p:spPr>
           <a:xfrm xmlns:a="http://schemas.openxmlformats.org/drawingml/2006/main">
             <a:off x="762000" y="5010150"/>
-            <a:ext cx="7620000" cy="990600"/>
+            <a:ext cx="3977639" cy="990600"/>
           </a:xfrm>
           <a:prstGeom xmlns:a="http://schemas.openxmlformats.org/drawingml/2006/main" prst="rect">
             <a:avLst/>
@@ -9963,7 +10285,40 @@
                 <a:ea typeface="Calibri"/>
                 <a:cs typeface="Calibri"/>
               </a:rPr>
-              <a:t>Arbetsgång: Beskriv en följd av hög felström, exempelvis värme eller brand. Hitta inte på ett amperetal.</a:t>
+              <a:t>Arbetsgång: Vad händer i slingan när </a:t>
+            </a:r>
+            <a:r>
+              <a:rPr sz="2025" b="0">
+                <a:solidFill>
+                  <a:srgbClr val="111111"/>
+                </a:solidFill>
+                <a:latin typeface="Calibri"/>
+                <a:ea typeface="Calibri"/>
+                <a:cs typeface="Calibri"/>
+              </a:rPr>
+              <a:t>R</a:t>
+            </a:r>
+            <a:r>
+              <a:rPr sz="2025" b="0" baseline="-25000">
+                <a:solidFill>
+                  <a:srgbClr val="111111"/>
+                </a:solidFill>
+                <a:latin typeface="Calibri"/>
+                <a:ea typeface="Calibri"/>
+                <a:cs typeface="Calibri"/>
+              </a:rPr>
+              <a:t>slinga</a:t>
+            </a:r>
+            <a:r>
+              <a:rPr sz="2025" b="0">
+                <a:solidFill>
+                  <a:srgbClr val="111111"/>
+                </a:solidFill>
+                <a:latin typeface="Calibri"/>
+                <a:ea typeface="Calibri"/>
+                <a:cs typeface="Calibri"/>
+              </a:rPr>
+              <a:t> är liten? Hitta inte på ett amperetal.</a:t>
             </a:r>
           </a:p>
         </p:txBody>
@@ -10025,6 +10380,30 @@
           </a:p>
         </p:txBody>
       </p:sp>
+      <p:pic xmlns:a="http://schemas.openxmlformats.org/drawingml/2006/main" xmlns:r="http://schemas.openxmlformats.org/officeDocument/2006/relationships">
+        <p:nvPicPr>
+          <p:cNvPr id="16" name="Figur: 24 V-batteri vars poler kortsluts av ett" descr="24 V-batteri vars poler kortsluts av ett verktyg; felströmmen ungefär U delat med slingans resistans"/>
+          <p:cNvPicPr>
+            <a:picLocks noChangeAspect="1"/>
+          </p:cNvPicPr>
+          <p:nvPr/>
+        </p:nvPicPr>
+        <p:blipFill>
+          <a:blip r:embed="rId3"/>
+          <a:stretch>
+            <a:fillRect/>
+          </a:stretch>
+        </p:blipFill>
+        <p:spPr>
+          <a:xfrm>
+            <a:off x="4892040" y="1645920"/>
+            <a:ext cx="3886200" cy="2890202"/>
+          </a:xfrm>
+          <a:prstGeom prst="rect">
+            <a:avLst/>
+          </a:prstGeom>
+        </p:spPr>
+      </p:pic>
     </p:spTree>
     <p:extLst>
       <p:ext uri="{BB962C8B-B14F-4D97-AF65-F5344CB8AC3E}">
@@ -10298,7 +10677,7 @@
                 <a:ea typeface="Calibri"/>
                 <a:cs typeface="Calibri"/>
               </a:rPr>
-              <a:t>Redovisa din beräkning eller motivera ditt beslut.</a:t>
+              <a:t>Motivera ditt beslut.</a:t>
             </a:r>
           </a:p>
         </p:txBody>
@@ -10630,7 +11009,7 @@
                 <a:ea typeface="Calibri"/>
                 <a:cs typeface="Calibri"/>
               </a:rPr>
-              <a:t>Förutsättningar: Platsen kan vara spänningssatt. Vid akut fara larmas 112. Vid högspänning säkrar ansvarig platsen.</a:t>
+              <a:t>Förutsättningar: Platsen kan vara spänningssatt. Larm enligt nödinstruktionen. Vid högspänning säkrar behörig person platsen.</a:t>
             </a:r>
           </a:p>
         </p:txBody>
@@ -11022,7 +11401,7 @@
                 <a:ea typeface="Calibri"/>
                 <a:cs typeface="Calibri"/>
               </a:rPr>
-              <a:t>Redovisa din beräkning eller motivera ditt beslut.</a:t>
+              <a:t>Motivera ditt beslut.</a:t>
             </a:r>
           </a:p>
         </p:txBody>
@@ -11411,7 +11790,7 @@
                 <a:ea typeface="Calibri"/>
                 <a:cs typeface="Calibri"/>
               </a:rPr>
-              <a:t>Arbetsgång: Rekommendera avbrott, säker plats och sjukvårdskontakt. Beskriv även rapportering enligt arbetsplatsens rutin.</a:t>
+              <a:t>Arbetsgång: Vad rekommenderar du, och varför? Beskriv även rapporteringen enligt rutinen ombord.</a:t>
             </a:r>
           </a:p>
         </p:txBody>
@@ -12260,7 +12639,7 @@
                 <a:ea typeface="Calibri"/>
                 <a:cs typeface="Calibri"/>
               </a:rPr>
-              <a:t>Redovisa din beräkning eller motivera ditt beslut.</a:t>
+              <a:t>Motivera ditt beslut.</a:t>
             </a:r>
           </a:p>
         </p:txBody>
@@ -12984,7 +13363,7 @@
                 <a:ea typeface="Calibri"/>
                 <a:cs typeface="Calibri"/>
               </a:rPr>
-              <a:t>Redovisa din beräkning eller motivera ditt beslut.</a:t>
+              <a:t>Motivera ditt beslut.</a:t>
             </a:r>
           </a:p>
         </p:txBody>
@@ -13708,7 +14087,7 @@
                 <a:ea typeface="Calibri"/>
                 <a:cs typeface="Calibri"/>
               </a:rPr>
-              <a:t>Redovisa din beräkning eller motivera ditt beslut.</a:t>
+              <a:t>Motivera ditt beslut.</a:t>
             </a:r>
           </a:p>
         </p:txBody>
@@ -13928,7 +14307,7 @@
                 <a:ea typeface="Calibri"/>
                 <a:cs typeface="Calibri"/>
               </a:rPr>
-              <a:t>Vilken uppgift saknas oftast när någon bara säger ”det är 24 V”?</a:t>
+              <a:t>Vilka uppgifter saknas oftast när någon bara säger ”det är 24 V”?</a:t>
             </a:r>
           </a:p>
         </p:txBody>
@@ -14414,64 +14793,6 @@
       </p:sp>
       <p:sp>
         <p:nvSpPr>
-          <p:cNvPr id="7" name="Källor och lärarstöd finns även i bildanteckningarna.">
-            <a:extLst xmlns:a="http://schemas.openxmlformats.org/drawingml/2006/main">
-              <a:ext uri="{FF2B5EF4-FFF2-40B4-BE49-F238E27FC236}">
-                <a16:creationId xmlns:a16="http://schemas.microsoft.com/office/drawing/2014/main" id="{AFE2E5B0-656F-4861-953F-CA0D662021A3}"/>
-              </a:ext>
-            </a:extLst>
-          </p:cNvPr>
-          <p:cNvSpPr>
-            <a:spLocks xmlns:a="http://schemas.openxmlformats.org/drawingml/2006/main" noGrp="1"/>
-          </p:cNvSpPr>
-          <p:nvPr/>
-        </p:nvSpPr>
-        <p:spPr>
-          <a:xfrm xmlns:a="http://schemas.openxmlformats.org/drawingml/2006/main">
-            <a:off x="762000" y="5676900"/>
-            <a:ext cx="7620000" cy="352425"/>
-          </a:xfrm>
-          <a:prstGeom xmlns:a="http://schemas.openxmlformats.org/drawingml/2006/main" prst="rect">
-            <a:avLst/>
-          </a:prstGeom>
-          <a:noFill xmlns:a="http://schemas.openxmlformats.org/drawingml/2006/main"/>
-          <a:ln xmlns:a="http://schemas.openxmlformats.org/drawingml/2006/main" w="0">
-            <a:noFill/>
-          </a:ln>
-        </p:spPr>
-        <p:txBody>
-          <a:bodyPr xmlns:a="http://schemas.openxmlformats.org/drawingml/2006/main" wrap="square" lIns="0" tIns="0" rIns="0" bIns="0" anchor="t">
-            <a:noAutofit/>
-          </a:bodyPr>
-          <a:lstStyle xmlns:a="http://schemas.openxmlformats.org/drawingml/2006/main"/>
-          <a:p xmlns:a="http://schemas.openxmlformats.org/drawingml/2006/main">
-            <a:pPr algn="l">
-              <a:buNone/>
-              <a:defRPr sz="1800" b="0">
-                <a:solidFill>
-                  <a:srgbClr val="111111"/>
-                </a:solidFill>
-                <a:latin typeface="Calibri"/>
-                <a:ea typeface="Calibri"/>
-                <a:cs typeface="Calibri"/>
-              </a:defRPr>
-            </a:pPr>
-            <a:r>
-              <a:rPr sz="1800" b="0">
-                <a:solidFill>
-                  <a:srgbClr val="111111"/>
-                </a:solidFill>
-                <a:latin typeface="Calibri"/>
-                <a:ea typeface="Calibri"/>
-                <a:cs typeface="Calibri"/>
-              </a:rPr>
-              <a:t>Källor och lärarstöd finns även i bildanteckningarna.</a:t>
-            </a:r>
-          </a:p>
-        </p:txBody>
-      </p:sp>
-      <p:sp>
-        <p:nvSpPr>
           <p:cNvPr id="8" name="22">
             <a:extLst xmlns:a="http://schemas.openxmlformats.org/drawingml/2006/main">
               <a:ext uri="{FF2B5EF4-FFF2-40B4-BE49-F238E27FC236}">
@@ -15562,7 +15883,7 @@
         <p:spPr>
           <a:xfrm xmlns:a="http://schemas.openxmlformats.org/drawingml/2006/main">
             <a:off x="762000" y="1619250"/>
-            <a:ext cx="7620000" cy="1466850"/>
+            <a:ext cx="3977639" cy="1466850"/>
           </a:xfrm>
           <a:prstGeom xmlns:a="http://schemas.openxmlformats.org/drawingml/2006/main" prst="rect">
             <a:avLst/>
@@ -15590,7 +15911,7 @@
               </a:defRPr>
             </a:pPr>
             <a:r>
-              <a:rPr sz="2400" b="0">
+              <a:rPr sz="1900" b="0">
                 <a:solidFill>
                   <a:srgbClr val="111111"/>
                 </a:solidFill>
@@ -15614,7 +15935,7 @@
               </a:defRPr>
             </a:pPr>
             <a:r>
-              <a:rPr sz="2400" b="0">
+              <a:rPr sz="1900" b="0">
                 <a:solidFill>
                   <a:srgbClr val="111111"/>
                 </a:solidFill>
@@ -15644,7 +15965,7 @@
         <p:spPr>
           <a:xfrm xmlns:a="http://schemas.openxmlformats.org/drawingml/2006/main">
             <a:off x="762000" y="3200400"/>
-            <a:ext cx="7620000" cy="838200"/>
+            <a:ext cx="3977639" cy="838200"/>
           </a:xfrm>
           <a:prstGeom xmlns:a="http://schemas.openxmlformats.org/drawingml/2006/main" prst="rect">
             <a:avLst/>
@@ -15672,7 +15993,7 @@
               </a:defRPr>
             </a:pPr>
             <a:r>
-              <a:rPr sz="2925" b="1">
+              <a:rPr sz="2650" b="1">
                 <a:solidFill>
                   <a:srgbClr val="064F91"/>
                 </a:solidFill>
@@ -15702,7 +16023,7 @@
         <p:spPr>
           <a:xfrm xmlns:a="http://schemas.openxmlformats.org/drawingml/2006/main">
             <a:off x="762000" y="4429125"/>
-            <a:ext cx="7620000" cy="1352550"/>
+            <a:ext cx="3977639" cy="1352550"/>
           </a:xfrm>
           <a:prstGeom xmlns:a="http://schemas.openxmlformats.org/drawingml/2006/main" prst="rect">
             <a:avLst/>
@@ -15730,7 +16051,7 @@
               </a:defRPr>
             </a:pPr>
             <a:r>
-              <a:rPr sz="2250" b="0">
+              <a:rPr sz="2000" b="0">
                 <a:solidFill>
                   <a:srgbClr val="111111"/>
                 </a:solidFill>
@@ -15754,7 +16075,7 @@
               </a:defRPr>
             </a:pPr>
             <a:r>
-              <a:rPr sz="2250" b="0">
+              <a:rPr sz="2000" b="0">
                 <a:solidFill>
                   <a:srgbClr val="111111"/>
                 </a:solidFill>
@@ -15825,6 +16146,30 @@
           </a:p>
         </p:txBody>
       </p:sp>
+      <p:pic xmlns:a="http://schemas.openxmlformats.org/drawingml/2006/main" xmlns:r="http://schemas.openxmlformats.org/officeDocument/2006/relationships">
+        <p:nvPicPr>
+          <p:cNvPr id="9" name="Figur: Figur med två strömvägar genom kroppen: " descr="Figur med två strömvägar genom kroppen: hand till hand och hand till fot; båda passerar bröstkorgen nära hjärtat"/>
+          <p:cNvPicPr>
+            <a:picLocks noChangeAspect="1"/>
+          </p:cNvPicPr>
+          <p:nvPr/>
+        </p:nvPicPr>
+        <p:blipFill>
+          <a:blip r:embed="rId3"/>
+          <a:stretch>
+            <a:fillRect/>
+          </a:stretch>
+        </p:blipFill>
+        <p:spPr>
+          <a:xfrm>
+            <a:off x="4892040" y="1645920"/>
+            <a:ext cx="3886200" cy="3795655"/>
+          </a:xfrm>
+          <a:prstGeom prst="rect">
+            <a:avLst/>
+          </a:prstGeom>
+        </p:spPr>
+      </p:pic>
     </p:spTree>
     <p:extLst>
       <p:ext uri="{BB962C8B-B14F-4D97-AF65-F5344CB8AC3E}">
@@ -15946,7 +16291,7 @@
         <p:spPr>
           <a:xfrm xmlns:a="http://schemas.openxmlformats.org/drawingml/2006/main">
             <a:off x="762000" y="1619250"/>
-            <a:ext cx="7620000" cy="1466850"/>
+            <a:ext cx="3977639" cy="1466850"/>
           </a:xfrm>
           <a:prstGeom xmlns:a="http://schemas.openxmlformats.org/drawingml/2006/main" prst="rect">
             <a:avLst/>
@@ -15974,7 +16319,7 @@
               </a:defRPr>
             </a:pPr>
             <a:r>
-              <a:rPr sz="2400" b="0">
+              <a:rPr sz="1950" b="0">
                 <a:solidFill>
                   <a:srgbClr val="111111"/>
                 </a:solidFill>
@@ -15998,7 +16343,7 @@
               </a:defRPr>
             </a:pPr>
             <a:r>
-              <a:rPr sz="2400" b="0">
+              <a:rPr sz="1950" b="0">
                 <a:solidFill>
                   <a:srgbClr val="111111"/>
                 </a:solidFill>
@@ -16028,7 +16373,7 @@
         <p:spPr>
           <a:xfrm xmlns:a="http://schemas.openxmlformats.org/drawingml/2006/main">
             <a:off x="762000" y="3200400"/>
-            <a:ext cx="7620000" cy="838200"/>
+            <a:ext cx="3977639" cy="838200"/>
           </a:xfrm>
           <a:prstGeom xmlns:a="http://schemas.openxmlformats.org/drawingml/2006/main" prst="rect">
             <a:avLst/>
@@ -16056,7 +16401,7 @@
               </a:defRPr>
             </a:pPr>
             <a:r>
-              <a:rPr sz="2925" b="1">
+              <a:rPr sz="2650" b="1">
                 <a:solidFill>
                   <a:srgbClr val="064F91"/>
                 </a:solidFill>
@@ -16064,7 +16409,7 @@
                 <a:ea typeface="Calibri"/>
                 <a:cs typeface="Calibri"/>
               </a:rPr>
-              <a:t>I = U/R är en förenklad beräkningsmodell</a:t>
+              <a:t>I = U/R är en förenklad beräkningsmodell</a:t>
             </a:r>
           </a:p>
         </p:txBody>
@@ -16086,7 +16431,7 @@
         <p:spPr>
           <a:xfrm xmlns:a="http://schemas.openxmlformats.org/drawingml/2006/main">
             <a:off x="762000" y="4429125"/>
-            <a:ext cx="7620000" cy="1352550"/>
+            <a:ext cx="3977639" cy="1352550"/>
           </a:xfrm>
           <a:prstGeom xmlns:a="http://schemas.openxmlformats.org/drawingml/2006/main" prst="rect">
             <a:avLst/>
@@ -16114,7 +16459,7 @@
               </a:defRPr>
             </a:pPr>
             <a:r>
-              <a:rPr sz="2250" b="0">
+              <a:rPr sz="2000" b="0">
                 <a:solidFill>
                   <a:srgbClr val="111111"/>
                 </a:solidFill>
@@ -16138,7 +16483,7 @@
               </a:defRPr>
             </a:pPr>
             <a:r>
-              <a:rPr sz="2250" b="0">
+              <a:rPr sz="2000" b="0">
                 <a:solidFill>
                   <a:srgbClr val="111111"/>
                 </a:solidFill>
@@ -16209,6 +16554,30 @@
           </a:p>
         </p:txBody>
       </p:sp>
+      <p:pic xmlns:a="http://schemas.openxmlformats.org/drawingml/2006/main" xmlns:r="http://schemas.openxmlformats.org/officeDocument/2006/relationships">
+        <p:nvPicPr>
+          <p:cNvPr id="9" name="Figur: Metallhölje med isolationsfel och bruten" descr="Metallhölje med isolationsfel och bruten skyddsledare; en person rör höljet och står på ledande stålskrov. Beröringsspänningen är skillnaden mellan höljets och däckets potential"/>
+          <p:cNvPicPr>
+            <a:picLocks noChangeAspect="1"/>
+          </p:cNvPicPr>
+          <p:nvPr/>
+        </p:nvPicPr>
+        <p:blipFill>
+          <a:blip r:embed="rId3"/>
+          <a:stretch>
+            <a:fillRect/>
+          </a:stretch>
+        </p:blipFill>
+        <p:spPr>
+          <a:xfrm>
+            <a:off x="4892040" y="1645920"/>
+            <a:ext cx="3886200" cy="3795655"/>
+          </a:xfrm>
+          <a:prstGeom prst="rect">
+            <a:avLst/>
+          </a:prstGeom>
+        </p:spPr>
+      </p:pic>
     </p:spTree>
     <p:extLst>
       <p:ext uri="{BB962C8B-B14F-4D97-AF65-F5344CB8AC3E}">
@@ -16330,7 +16699,7 @@
         <p:spPr>
           <a:xfrm xmlns:a="http://schemas.openxmlformats.org/drawingml/2006/main">
             <a:off x="762000" y="1619250"/>
-            <a:ext cx="7620000" cy="1466850"/>
+            <a:ext cx="3977639" cy="1466850"/>
           </a:xfrm>
           <a:prstGeom xmlns:a="http://schemas.openxmlformats.org/drawingml/2006/main" prst="rect">
             <a:avLst/>
@@ -16358,7 +16727,7 @@
               </a:defRPr>
             </a:pPr>
             <a:r>
-              <a:rPr sz="2400" b="0">
+              <a:rPr sz="1900" b="0">
                 <a:solidFill>
                   <a:srgbClr val="111111"/>
                 </a:solidFill>
@@ -16382,7 +16751,7 @@
               </a:defRPr>
             </a:pPr>
             <a:r>
-              <a:rPr sz="2400" b="0">
+              <a:rPr sz="1900" b="0">
                 <a:solidFill>
                   <a:srgbClr val="111111"/>
                 </a:solidFill>
@@ -16412,7 +16781,7 @@
         <p:spPr>
           <a:xfrm xmlns:a="http://schemas.openxmlformats.org/drawingml/2006/main">
             <a:off x="762000" y="3200400"/>
-            <a:ext cx="7620000" cy="838200"/>
+            <a:ext cx="3977639" cy="838200"/>
           </a:xfrm>
           <a:prstGeom xmlns:a="http://schemas.openxmlformats.org/drawingml/2006/main" prst="rect">
             <a:avLst/>
@@ -16440,7 +16809,7 @@
               </a:defRPr>
             </a:pPr>
             <a:r>
-              <a:rPr sz="2925" b="1">
+              <a:rPr sz="2400" b="1">
                 <a:solidFill>
                   <a:srgbClr val="064F91"/>
                 </a:solidFill>
@@ -16470,7 +16839,7 @@
         <p:spPr>
           <a:xfrm xmlns:a="http://schemas.openxmlformats.org/drawingml/2006/main">
             <a:off x="762000" y="4429125"/>
-            <a:ext cx="7620000" cy="1352550"/>
+            <a:ext cx="3977639" cy="1352550"/>
           </a:xfrm>
           <a:prstGeom xmlns:a="http://schemas.openxmlformats.org/drawingml/2006/main" prst="rect">
             <a:avLst/>
@@ -16498,7 +16867,7 @@
               </a:defRPr>
             </a:pPr>
             <a:r>
-              <a:rPr sz="2250" b="0">
+              <a:rPr sz="1850" b="0">
                 <a:solidFill>
                   <a:srgbClr val="111111"/>
                 </a:solidFill>
@@ -16522,7 +16891,7 @@
               </a:defRPr>
             </a:pPr>
             <a:r>
-              <a:rPr sz="2250" b="0">
+              <a:rPr sz="1850" b="0">
                 <a:solidFill>
                   <a:srgbClr val="111111"/>
                 </a:solidFill>
@@ -16593,6 +16962,30 @@
           </a:p>
         </p:txBody>
       </p:sp>
+      <p:pic xmlns:a="http://schemas.openxmlformats.org/drawingml/2006/main" xmlns:r="http://schemas.openxmlformats.org/officeDocument/2006/relationships">
+        <p:nvPicPr>
+          <p:cNvPr id="9" name="Figur: Ljusbåge mellan två strömskenor med pila" descr="Ljusbåge mellan två strömskenor med pilar för värme, tryck, starkt ljus och splitter"/>
+          <p:cNvPicPr>
+            <a:picLocks noChangeAspect="1"/>
+          </p:cNvPicPr>
+          <p:nvPr/>
+        </p:nvPicPr>
+        <p:blipFill>
+          <a:blip r:embed="rId3"/>
+          <a:stretch>
+            <a:fillRect/>
+          </a:stretch>
+        </p:blipFill>
+        <p:spPr>
+          <a:xfrm>
+            <a:off x="4892040" y="1645920"/>
+            <a:ext cx="3886200" cy="3252383"/>
+          </a:xfrm>
+          <a:prstGeom prst="rect">
+            <a:avLst/>
+          </a:prstGeom>
+        </p:spPr>
+      </p:pic>
     </p:spTree>
     <p:extLst>
       <p:ext uri="{BB962C8B-B14F-4D97-AF65-F5344CB8AC3E}">
@@ -16713,7 +17106,7 @@
         <p:spPr>
           <a:xfrm xmlns:a="http://schemas.openxmlformats.org/drawingml/2006/main">
             <a:off x="762000" y="1571625"/>
-            <a:ext cx="7620000" cy="990600"/>
+            <a:ext cx="3977639" cy="990600"/>
           </a:xfrm>
           <a:prstGeom xmlns:a="http://schemas.openxmlformats.org/drawingml/2006/main" prst="rect">
             <a:avLst/>
@@ -16740,7 +17133,7 @@
               </a:defRPr>
             </a:pPr>
             <a:r>
-              <a:rPr sz="2175" b="0">
+              <a:rPr sz="2100" b="0">
                 <a:solidFill>
                   <a:srgbClr val="111111"/>
                 </a:solidFill>
@@ -16770,7 +17163,7 @@
         <p:spPr>
           <a:xfrm xmlns:a="http://schemas.openxmlformats.org/drawingml/2006/main">
             <a:off x="762000" y="2705100"/>
-            <a:ext cx="7620000" cy="790575"/>
+            <a:ext cx="3977639" cy="790575"/>
           </a:xfrm>
           <a:prstGeom xmlns:a="http://schemas.openxmlformats.org/drawingml/2006/main" prst="rect">
             <a:avLst/>
@@ -16827,7 +17220,7 @@
         <p:spPr>
           <a:xfrm xmlns:a="http://schemas.openxmlformats.org/drawingml/2006/main">
             <a:off x="762000" y="3657600"/>
-            <a:ext cx="7620000" cy="1524000"/>
+            <a:ext cx="3977639" cy="1524000"/>
           </a:xfrm>
           <a:prstGeom xmlns:a="http://schemas.openxmlformats.org/drawingml/2006/main" prst="rect">
             <a:avLst/>
@@ -16854,7 +17247,7 @@
               </a:defRPr>
             </a:pPr>
             <a:r>
-              <a:rPr sz="2063" b="0">
+              <a:rPr sz="1650" b="0">
                 <a:solidFill>
                   <a:srgbClr val="111111"/>
                 </a:solidFill>
@@ -16877,7 +17270,7 @@
               </a:defRPr>
             </a:pPr>
             <a:r>
-              <a:rPr sz="2063" b="0">
+              <a:rPr sz="1650" b="0">
                 <a:solidFill>
                   <a:srgbClr val="111111"/>
                 </a:solidFill>
@@ -16900,7 +17293,7 @@
               </a:defRPr>
             </a:pPr>
             <a:r>
-              <a:rPr sz="2063" b="0">
+              <a:rPr sz="1650" b="0">
                 <a:solidFill>
                   <a:srgbClr val="111111"/>
                 </a:solidFill>
@@ -16930,7 +17323,7 @@
         <p:spPr>
           <a:xfrm xmlns:a="http://schemas.openxmlformats.org/drawingml/2006/main">
             <a:off x="762000" y="5372100"/>
-            <a:ext cx="7620000" cy="685800"/>
+            <a:ext cx="3977639" cy="685800"/>
           </a:xfrm>
           <a:prstGeom xmlns:a="http://schemas.openxmlformats.org/drawingml/2006/main" prst="rect">
             <a:avLst/>
@@ -16957,7 +17350,7 @@
               </a:defRPr>
             </a:pPr>
             <a:r>
-              <a:rPr sz="1913" b="0">
+              <a:rPr sz="1550" b="0">
                 <a:solidFill>
                   <a:srgbClr val="111111"/>
                 </a:solidFill>
@@ -17027,6 +17420,30 @@
           </a:p>
         </p:txBody>
       </p:sp>
+      <p:pic xmlns:a="http://schemas.openxmlformats.org/drawingml/2006/main" xmlns:r="http://schemas.openxmlformats.org/officeDocument/2006/relationships">
+        <p:nvPicPr>
+          <p:cNvPr id="16" name="Figur: Skadad skarvkabel i vatten på däck, avsp" descr="Skadad skarvkabel i vatten på däck, avspärrad med band"/>
+          <p:cNvPicPr>
+            <a:picLocks noChangeAspect="1"/>
+          </p:cNvPicPr>
+          <p:nvPr/>
+        </p:nvPicPr>
+        <p:blipFill>
+          <a:blip r:embed="rId3"/>
+          <a:stretch>
+            <a:fillRect/>
+          </a:stretch>
+        </p:blipFill>
+        <p:spPr>
+          <a:xfrm>
+            <a:off x="4892040" y="1645920"/>
+            <a:ext cx="3886200" cy="2890202"/>
+          </a:xfrm>
+          <a:prstGeom prst="rect">
+            <a:avLst/>
+          </a:prstGeom>
+        </p:spPr>
+      </p:pic>
     </p:spTree>
     <p:extLst>
       <p:ext uri="{BB962C8B-B14F-4D97-AF65-F5344CB8AC3E}">

</xml_diff>

<commit_message>
Sjöskolan vecka 42: rätta exempel som gav övningarnas svar, förenkla texter, nya förkortningar
Riskexemplet (5 · 3 → 2 · 3), exemplen i del 1 och 2, sambandet i övning 2.2, V_{A}/V_{B} i 1.3,
klippta figurer, förkortningar i beteckningar.json och enklare frågor och ledtrådar.
Inlämning 2 d och 3 är entydiga; D = 12 för alla.

Co-Authored-By: Claude Opus 5.5 <noreply@anthropic.com>
Claude-Session: https://claude.ai/code/session_01E6DNWu8trXB9zSZC1cgTtp
</commit_message>
<xml_diff>
--- a/sjoskolan/vecka-42/aktuell/v42_01_Elektriska_risker_elev.pptx
+++ b/sjoskolan/vecka-42/aktuell/v42_01_Elektriska_risker_elev.pptx
@@ -5316,7 +5316,51 @@
                 <a:ea typeface="Calibri"/>
                 <a:cs typeface="Calibri"/>
               </a:rPr>
-              <a:t> = |VA − VB|</a:t>
+              <a:t> = |V</a:t>
+            </a:r>
+            <a:r>
+              <a:rPr sz="2400" b="1" baseline="-25000">
+                <a:solidFill>
+                  <a:srgbClr val="064F91"/>
+                </a:solidFill>
+                <a:latin typeface="Calibri"/>
+                <a:ea typeface="Calibri"/>
+                <a:cs typeface="Calibri"/>
+              </a:rPr>
+              <a:t>A</a:t>
+            </a:r>
+            <a:r>
+              <a:rPr sz="2400" b="1">
+                <a:solidFill>
+                  <a:srgbClr val="064F91"/>
+                </a:solidFill>
+                <a:latin typeface="Calibri"/>
+                <a:ea typeface="Calibri"/>
+                <a:cs typeface="Calibri"/>
+              </a:rPr>
+              <a:t> − V</a:t>
+            </a:r>
+            <a:r>
+              <a:rPr sz="2400" b="1" baseline="-25000">
+                <a:solidFill>
+                  <a:srgbClr val="064F91"/>
+                </a:solidFill>
+                <a:latin typeface="Calibri"/>
+                <a:ea typeface="Calibri"/>
+                <a:cs typeface="Calibri"/>
+              </a:rPr>
+              <a:t>B</a:t>
+            </a:r>
+            <a:r>
+              <a:rPr sz="2400" b="1">
+                <a:solidFill>
+                  <a:srgbClr val="064F91"/>
+                </a:solidFill>
+                <a:latin typeface="Calibri"/>
+                <a:ea typeface="Calibri"/>
+                <a:cs typeface="Calibri"/>
+              </a:rPr>
+              <a:t>|</a:t>
             </a:r>
           </a:p>
         </p:txBody>
@@ -5373,7 +5417,51 @@
                 <a:ea typeface="Calibri"/>
                 <a:cs typeface="Calibri"/>
               </a:rPr>
-              <a:t>VA och VB är spänningen i de två punkter som kan röras samtidigt.</a:t>
+              <a:t>V</a:t>
+            </a:r>
+            <a:r>
+              <a:rPr sz="2050" b="0" baseline="-25000">
+                <a:solidFill>
+                  <a:srgbClr val="111111"/>
+                </a:solidFill>
+                <a:latin typeface="Calibri"/>
+                <a:ea typeface="Calibri"/>
+                <a:cs typeface="Calibri"/>
+              </a:rPr>
+              <a:t>A</a:t>
+            </a:r>
+            <a:r>
+              <a:rPr sz="2050" b="0">
+                <a:solidFill>
+                  <a:srgbClr val="111111"/>
+                </a:solidFill>
+                <a:latin typeface="Calibri"/>
+                <a:ea typeface="Calibri"/>
+                <a:cs typeface="Calibri"/>
+              </a:rPr>
+              <a:t> och V</a:t>
+            </a:r>
+            <a:r>
+              <a:rPr sz="2050" b="0" baseline="-25000">
+                <a:solidFill>
+                  <a:srgbClr val="111111"/>
+                </a:solidFill>
+                <a:latin typeface="Calibri"/>
+                <a:ea typeface="Calibri"/>
+                <a:cs typeface="Calibri"/>
+              </a:rPr>
+              <a:t>B</a:t>
+            </a:r>
+            <a:r>
+              <a:rPr sz="2050" b="0">
+                <a:solidFill>
+                  <a:srgbClr val="111111"/>
+                </a:solidFill>
+                <a:latin typeface="Calibri"/>
+                <a:ea typeface="Calibri"/>
+                <a:cs typeface="Calibri"/>
+              </a:rPr>
+              <a:t> är potentialen i punkterna A och B, mätt mot samma referens, till exempel skrovet.</a:t>
             </a:r>
           </a:p>
         </p:txBody>
@@ -6306,7 +6394,7 @@
           <p:nvPr/>
         </p:nvPicPr>
         <p:blipFill>
-          <a:blip r:embed="rId3"/>
+          <a:blip r:embed="rId4"/>
           <a:stretch>
             <a:fillRect/>
           </a:stretch>
@@ -9504,7 +9592,7 @@
                 <a:ea typeface="Calibri"/>
                 <a:cs typeface="Calibri"/>
               </a:rPr>
-              <a:t>En skadad prob upptäcks före användning. Mätningen har ännu inte påbörjats.</a:t>
+              <a:t>Ett låsbleck för frånskiljaren är böjt och går inte att stänga. Det upptäcks innan arbetet börjar.</a:t>
             </a:r>
           </a:p>
         </p:txBody>
@@ -9618,7 +9706,7 @@
                 <a:ea typeface="Calibri"/>
                 <a:cs typeface="Calibri"/>
               </a:rPr>
-              <a:t>1. Ta den skadade proben ur bruk och märk enligt rutinen.</a:t>
+              <a:t>1. Ta det böjda låsblecket ur bruk och märk det enligt rutinen.</a:t>
             </a:r>
           </a:p>
           <a:p xmlns:a="http://schemas.openxmlformats.org/drawingml/2006/main">
@@ -9641,7 +9729,7 @@
                 <a:ea typeface="Calibri"/>
                 <a:cs typeface="Calibri"/>
               </a:rPr>
-              <a:t>2. Ordna avsedd, kontrollerad utrustning innan mätningen.</a:t>
+              <a:t>2. Hämta ett helt låsbleck innan frånskiljaren låses.</a:t>
             </a:r>
           </a:p>
           <a:p xmlns:a="http://schemas.openxmlformats.org/drawingml/2006/main">
@@ -9664,7 +9752,7 @@
                 <a:ea typeface="Calibri"/>
                 <a:cs typeface="Calibri"/>
               </a:rPr>
-              <a:t>3. Följ upp hur skadan uppstod och hur förkontrollen fungerar.</a:t>
+              <a:t>3. Följ upp hur skadan uppstod och om låsutrustningen kontrolleras före användning.</a:t>
             </a:r>
           </a:p>
         </p:txBody>
@@ -10487,7 +10575,7 @@
                 <a:ea typeface="Calibri"/>
                 <a:cs typeface="Calibri"/>
               </a:rPr>
-              <a:t>Ett 24 V-batteri har stor kortslutningsförmåga. Ange en viktig risk som inte avgörs av spänningstalet ensamt.</a:t>
+              <a:t>Ett 24 V-batteri kan ge en mycket stor ström om polerna kortsluts. Vilken risk finns, fast spänningen är låg?</a:t>
             </a:r>
           </a:p>
         </p:txBody>
@@ -17001,15 +17089,15 @@
               </a:defRPr>
             </a:pPr>
             <a:r>
-              <a:rPr sz="2100" b="0">
-                <a:solidFill>
-                  <a:srgbClr val="111111"/>
-                </a:solidFill>
-                <a:latin typeface="Calibri"/>
-                <a:ea typeface="Calibri"/>
-                <a:cs typeface="Calibri"/>
-              </a:rPr>
-              <a:t>En skadad skarvkabel ligger där vatten samlas. Ingen berör den just nu.</a:t>
+              <a:rPr sz="1800" b="0">
+                <a:solidFill>
+                  <a:srgbClr val="111111"/>
+                </a:solidFill>
+                <a:latin typeface="Calibri"/>
+                <a:ea typeface="Calibri"/>
+                <a:cs typeface="Calibri"/>
+              </a:rPr>
+              <a:t>En vinkelslip i verkstaden har en kabel som legat klämd under en tung låda. Ingen använder maskinen just nu.</a:t>
             </a:r>
           </a:p>
         </p:txBody>
@@ -17115,15 +17203,15 @@
               </a:defRPr>
             </a:pPr>
             <a:r>
-              <a:rPr sz="1650" b="0">
-                <a:solidFill>
-                  <a:srgbClr val="111111"/>
-                </a:solidFill>
-                <a:latin typeface="Calibri"/>
-                <a:ea typeface="Calibri"/>
-                <a:cs typeface="Calibri"/>
-              </a:rPr>
-              <a:t>1. Observation: synlig kabelskada och vatten i området.</a:t>
+              <a:rPr sz="1500" b="0">
+                <a:solidFill>
+                  <a:srgbClr val="111111"/>
+                </a:solidFill>
+                <a:latin typeface="Calibri"/>
+                <a:ea typeface="Calibri"/>
+                <a:cs typeface="Calibri"/>
+              </a:rPr>
+              <a:t>1. Observation: kabeln är tillplattad och manteln har en spricka.</a:t>
             </a:r>
           </a:p>
           <a:p xmlns:a="http://schemas.openxmlformats.org/drawingml/2006/main">
@@ -17138,15 +17226,15 @@
               </a:defRPr>
             </a:pPr>
             <a:r>
-              <a:rPr sz="1650" b="0">
-                <a:solidFill>
-                  <a:srgbClr val="111111"/>
-                </a:solidFill>
-                <a:latin typeface="Calibri"/>
-                <a:ea typeface="Calibri"/>
-                <a:cs typeface="Calibri"/>
-              </a:rPr>
-              <a:t>2. Möjlig händelse: en person berör en del vars isolation brustit.</a:t>
+              <a:rPr sz="1500" b="0">
+                <a:solidFill>
+                  <a:srgbClr val="111111"/>
+                </a:solidFill>
+                <a:latin typeface="Calibri"/>
+                <a:ea typeface="Calibri"/>
+                <a:cs typeface="Calibri"/>
+              </a:rPr>
+              <a:t>2. Möjlig händelse: någon håller i maskinen och rör en del där isolationen är trasig.</a:t>
             </a:r>
           </a:p>
           <a:p xmlns:a="http://schemas.openxmlformats.org/drawingml/2006/main">
@@ -17161,15 +17249,15 @@
               </a:defRPr>
             </a:pPr>
             <a:r>
-              <a:rPr sz="1650" b="0">
-                <a:solidFill>
-                  <a:srgbClr val="111111"/>
-                </a:solidFill>
-                <a:latin typeface="Calibri"/>
-                <a:ea typeface="Calibri"/>
-                <a:cs typeface="Calibri"/>
-              </a:rPr>
-              <a:t>3. Möjlig följd: strömgenomgång eller fallskada.</a:t>
+              <a:rPr sz="1500" b="0">
+                <a:solidFill>
+                  <a:srgbClr val="111111"/>
+                </a:solidFill>
+                <a:latin typeface="Calibri"/>
+                <a:ea typeface="Calibri"/>
+                <a:cs typeface="Calibri"/>
+              </a:rPr>
+              <a:t>3. Möjlig följd: strömgenomgång, eller att personen tappar maskinen och skadar sig.</a:t>
             </a:r>
           </a:p>
         </p:txBody>
@@ -17218,15 +17306,15 @@
               </a:defRPr>
             </a:pPr>
             <a:r>
-              <a:rPr sz="1550" b="0">
-                <a:solidFill>
-                  <a:srgbClr val="111111"/>
-                </a:solidFill>
-                <a:latin typeface="Calibri"/>
-                <a:ea typeface="Calibri"/>
-                <a:cs typeface="Calibri"/>
-              </a:rPr>
-              <a:t>Spänningssättning är ännu inte verifierad. Den synliga skadan räcker för att stoppa användningen.</a:t>
+              <a:rPr sz="1400" b="0">
+                <a:solidFill>
+                  <a:srgbClr val="111111"/>
+                </a:solidFill>
+                <a:latin typeface="Calibri"/>
+                <a:ea typeface="Calibri"/>
+                <a:cs typeface="Calibri"/>
+              </a:rPr>
+              <a:t>Ingen vet om kabeln är spänningssatt. Den synliga skadan räcker för att stoppa användningen.</a:t>
             </a:r>
           </a:p>
         </p:txBody>
@@ -17290,14 +17378,14 @@
       </p:sp>
       <p:pic xmlns:a="http://schemas.openxmlformats.org/drawingml/2006/main" xmlns:r="http://schemas.openxmlformats.org/officeDocument/2006/relationships">
         <p:nvPicPr>
-          <p:cNvPr id="16" name="Figur: Skadad skarvkabel i vatten på däck, avsp" descr="Skadad skarvkabel i vatten på däck, avspärrad med band"/>
+          <p:cNvPr id="16" name="Figur: Vinkelslip på en arbetsbänk vars kabel h" descr="Vinkelslip på en arbetsbänk vars kabel har legat klämd under en tung låda: kabeln är tillplattad och manteln har en spricka; maskinen används inte tills vidare beslut"/>
           <p:cNvPicPr>
             <a:picLocks noChangeAspect="1"/>
           </p:cNvPicPr>
           <p:nvPr/>
         </p:nvPicPr>
         <p:blipFill>
-          <a:blip r:embed="rId3"/>
+          <a:blip r:embed="rId4"/>
           <a:stretch>
             <a:fillRect/>
           </a:stretch>

</xml_diff>

<commit_message>
Sjöskolan vecka 42 tisdag: fokuserad presentation och regelkartan för fartyg
Regler, ansvar och arbetsmetoder har nu 20 bilder i lektionsmallen. Avsnitt 6 visar vilka
regler som gäller vilka fartyg: TSFS 2017:26 (nationell sjöfart), TSFS 2019:4 (internationella
certifikat), TSFS 2019:56 (arbetsmiljö, redaren som arbetsgivare) och ISM-kodens SMS.
Delsidan del 2 har samma avsnitt och figurer. Start- och avslutsfrågorna för del 2 och 3 har
rätt kursplanspunkter. Mallen hanterar långa rubriker och källor.

Co-Authored-By: Claude Opus 5.5 <noreply@anthropic.com>
Claude-Session: https://claude.ai/code/session_01E6DNWu8trXB9zSZC1cgTtp
</commit_message>
<xml_diff>
--- a/sjoskolan/vecka-42/aktuell/v42_01_Elektriska_risker_elev.pptx
+++ b/sjoskolan/vecka-42/aktuell/v42_01_Elektriska_risker_elev.pptx
@@ -3508,7 +3508,7 @@
           <a:p>
             <a:pPr algn="l">
               <a:lnSpc>
-                <a:spcPct val="108000"/>
+                <a:spcPct val="95000"/>
               </a:lnSpc>
               <a:spcAft>
                 <a:spcPts val="0"/>
@@ -8141,7 +8141,7 @@
         <p:spPr>
           <a:xfrm>
             <a:off x="548640" y="1463040"/>
-            <a:ext cx="8046720" cy="411480"/>
+            <a:ext cx="8046720" cy="384048"/>
           </a:xfrm>
           <a:prstGeom prst="rect">
             <a:avLst/>
@@ -8184,7 +8184,7 @@
         <p:spPr>
           <a:xfrm>
             <a:off x="548640" y="1920240"/>
-            <a:ext cx="8046720" cy="411480"/>
+            <a:ext cx="8046720" cy="384048"/>
           </a:xfrm>
           <a:prstGeom prst="rect">
             <a:avLst/>
@@ -8226,7 +8226,7 @@
         <p:spPr>
           <a:xfrm>
             <a:off x="548640" y="2377440"/>
-            <a:ext cx="8046720" cy="411480"/>
+            <a:ext cx="8046720" cy="384048"/>
           </a:xfrm>
           <a:prstGeom prst="rect">
             <a:avLst/>
@@ -8269,7 +8269,7 @@
         <p:spPr>
           <a:xfrm>
             <a:off x="548640" y="2834640"/>
-            <a:ext cx="8046720" cy="411480"/>
+            <a:ext cx="8046720" cy="384048"/>
           </a:xfrm>
           <a:prstGeom prst="rect">
             <a:avLst/>
@@ -8312,7 +8312,7 @@
         <p:spPr>
           <a:xfrm>
             <a:off x="548640" y="3291840"/>
-            <a:ext cx="8046720" cy="411480"/>
+            <a:ext cx="8046720" cy="384048"/>
           </a:xfrm>
           <a:prstGeom prst="rect">
             <a:avLst/>

</xml_diff>

<commit_message>
Sjöskolan vecka 42: veckosidan visar dagen, lektionsdagar i egna färger och tydliga läxor
- Rutan I dag överst: dagens lektion med tid, vad vi pratar om (passen ur presentationen)
  och Öppna presentationen; efter lektionen läxorna; utan lektion närmaste sista dag och
  nästa lektion.
- En ruta per lektionsdag i egen färg (måndag grön, tisdag blå, fredag magenta) med
  upplägg, mål och läxor efter lektionen. Samma färg på presentationens titelbild.
- Hela veckan utan dagfärg: läsförståelsen (senast torsdag 15/10), inlämningen
  (senast söndag 18/10) och övningarna, med läget för varje.
- Läxorna skrivs en gång (lektioner.py HEMMA) och står både på bilden "Det här gör du nu"
  och på sidan.

Co-Authored-By: Claude Opus 5.5 <noreply@anthropic.com>
Claude-Session: https://claude.ai/code/session_01E6DNWu8trXB9zSZC1cgTtp
</commit_message>
<xml_diff>
--- a/sjoskolan/vecka-42/aktuell/v42_01_Elektriska_risker_elev.pptx
+++ b/sjoskolan/vecka-42/aktuell/v42_01_Elektriska_risker_elev.pptx
@@ -3652,9 +3652,64 @@
           </a:p>
         </p:txBody>
       </p:sp>
+      <p:sp>
+        <p:nvSpPr>
+          <p:cNvPr id="8" name="Dag: Måndag 12 oktober"/>
+          <p:cNvSpPr/>
+          <p:nvPr/>
+        </p:nvSpPr>
+        <p:spPr>
+          <a:xfrm>
+            <a:off x="548640" y="411480"/>
+            <a:ext cx="2944368" cy="438912"/>
+          </a:xfrm>
+          <a:prstGeom prst="roundRect">
+            <a:avLst>
+              <a:gd name="adj" fmla="val 18000"/>
+            </a:avLst>
+          </a:prstGeom>
+          <a:solidFill>
+            <a:srgbClr val="008300"/>
+          </a:solidFill>
+          <a:ln>
+            <a:noFill/>
+          </a:ln>
+          <a:effectLst/>
+        </p:spPr>
+        <p:style>
+          <a:lnRef idx="1">
+            <a:schemeClr val="accent1"/>
+          </a:lnRef>
+          <a:fillRef idx="3">
+            <a:schemeClr val="accent1"/>
+          </a:fillRef>
+          <a:effectRef idx="2">
+            <a:schemeClr val="accent1"/>
+          </a:effectRef>
+          <a:fontRef idx="minor">
+            <a:schemeClr val="lt1"/>
+          </a:fontRef>
+        </p:style>
+        <p:txBody>
+          <a:bodyPr rtlCol="0" anchor="ctr" lIns="109728" rIns="109728"/>
+          <a:lstStyle/>
+          <a:p>
+            <a:pPr algn="ctr"/>
+            <a:r>
+              <a:rPr sz="1800" b="1" i="0">
+                <a:solidFill>
+                  <a:srgbClr val="FFFFFF"/>
+                </a:solidFill>
+                <a:latin typeface="Calibri"/>
+              </a:rPr>
+              <a:t>Måndag 12 oktober</a:t>
+            </a:r>
+          </a:p>
+        </p:txBody>
+      </p:sp>
       <p:pic>
         <p:nvPicPr>
-          <p:cNvPr id="8" name="Picture 7" descr="sidfot.jpg"/>
+          <p:cNvPr id="9" name="Picture 8" descr="sidfot.jpg"/>
           <p:cNvPicPr>
             <a:picLocks noChangeAspect="1"/>
           </p:cNvPicPr>
@@ -3678,7 +3733,7 @@
       </p:pic>
       <p:sp>
         <p:nvSpPr>
-          <p:cNvPr id="9" name="TextBox 8"/>
+          <p:cNvPr id="10" name="TextBox 9"/>
           <p:cNvSpPr txBox="1"/>
           <p:nvPr/>
         </p:nvSpPr>
@@ -3720,7 +3775,7 @@
       </p:sp>
       <p:sp>
         <p:nvSpPr>
-          <p:cNvPr id="10" name="TextBox 9"/>
+          <p:cNvPr id="11" name="TextBox 10"/>
           <p:cNvSpPr txBox="1"/>
           <p:nvPr/>
         </p:nvSpPr>
@@ -7393,7 +7448,7 @@
                 </a:solidFill>
                 <a:latin typeface="Calibri"/>
               </a:rPr>
-              <a:t>1. Läs del 1 på webben. Tryck på ”Jag har läst del 1” längst ned på sidan.</a:t>
+              <a:t>1. Läs del 1. Tryck på ”Jag har läst del 1” längst ned på sidan.</a:t>
             </a:r>
           </a:p>
           <a:p>
@@ -7450,7 +7505,26 @@
                 </a:solidFill>
                 <a:latin typeface="Calibri"/>
               </a:rPr>
-              <a:t>4. I morgon tisdag 15.00: del 2, Regler, ansvar och arbetsmetoder.</a:t>
+              <a:t>4. Börja läsa de fyra texterna till Läsförståelse.</a:t>
+            </a:r>
+          </a:p>
+          <a:p>
+            <a:pPr algn="l">
+              <a:lnSpc>
+                <a:spcPct val="108000"/>
+              </a:lnSpc>
+              <a:spcAft>
+                <a:spcPts val="1400"/>
+              </a:spcAft>
+            </a:pPr>
+            <a:r>
+              <a:rPr sz="2000" b="0" i="0">
+                <a:solidFill>
+                  <a:srgbClr val="111111"/>
+                </a:solidFill>
+                <a:latin typeface="Calibri"/>
+              </a:rPr>
+              <a:t>5. I morgon tisdag 15.00: del 2, Regler, ansvar och arbetsmetoder.</a:t>
             </a:r>
           </a:p>
           <a:p>
@@ -7469,7 +7543,7 @@
                 </a:solidFill>
                 <a:latin typeface="Calibri"/>
               </a:rPr>
-              <a:t>Inlämningen för vecka 42 öppnar du från veckosidan. Sista dag: söndag 18 oktober.</a:t>
+              <a:t>Läsförståelsen senast torsdag 15 oktober, inlämningen senast söndag 18 oktober. Båda öppnar du från veckosidan.</a:t>
             </a:r>
           </a:p>
         </p:txBody>

</xml_diff>

<commit_message>
Sjöskolan vecka 42: läsuppgiften heter Quiz, och de fyra texterna går att ladda ner från veckosidan
Co-Authored-By: Claude Opus 5.5 <noreply@anthropic.com>
Claude-Session: https://claude.ai/code/session_01E6DNWu8trXB9zSZC1cgTtp
</commit_message>
<xml_diff>
--- a/sjoskolan/vecka-42/aktuell/v42_01_Elektriska_risker_elev.pptx
+++ b/sjoskolan/vecka-42/aktuell/v42_01_Elektriska_risker_elev.pptx
@@ -7505,7 +7505,7 @@
                 </a:solidFill>
                 <a:latin typeface="Calibri"/>
               </a:rPr>
-              <a:t>4. Börja läsa de fyra texterna till Läsförståelse.</a:t>
+              <a:t>4. Börja läsa de fyra texterna till veckans quiz.</a:t>
             </a:r>
           </a:p>
           <a:p>
@@ -7543,7 +7543,7 @@
                 </a:solidFill>
                 <a:latin typeface="Calibri"/>
               </a:rPr>
-              <a:t>Läsförståelsen senast torsdag 15 oktober, inlämningen senast söndag 18 oktober. Båda öppnar du från veckosidan.</a:t>
+              <a:t>Quizet senast torsdag 15 oktober, inlämningen senast söndag 18 oktober. Båda öppnar du från veckosidan.</a:t>
             </a:r>
           </a:p>
         </p:txBody>

</xml_diff>